<commit_message>
Updated hyperlinks in file
Fixed broken hyperlinks and added new ones.
</commit_message>
<xml_diff>
--- a/Reproducibility2026.pptx
+++ b/Reproducibility2026.pptx
@@ -12829,6 +12829,18 @@
             </a:r>
             <a:endParaRPr lang="en-US" dirty="0"/>
           </a:p>
+          <a:p>
+            <a:endParaRPr lang="en-US" dirty="0"/>
+          </a:p>
+          <a:p>
+            <a:r>
+              <a:rPr lang="en-US" dirty="0">
+                <a:hlinkClick r:id="rId5"/>
+              </a:rPr>
+              <a:t>Hack your way to scientific glory</a:t>
+            </a:r>
+            <a:endParaRPr lang="en-US" dirty="0"/>
+          </a:p>
         </p:txBody>
       </p:sp>
     </p:spTree>

</xml_diff>